<commit_message>
@ Add English presentation deck (9 slides, 16:9)
- slides/presentasi.pptx generated by slides/build_slides.py
- Covers: intro/objectives, data-gen equations, methods+formulas, results
  table, 3D/histogram visuals, noise analysis + robot-safety, conclusion
- Embeds existing figures and metrics.json values

Co-Authored-By: Claude Opus 4.8 <noreply@anthropic.com>
@
</commit_message>
<xml_diff>
--- a/slides/presentasi.pptx
+++ b/slides/presentasi.pptx
@@ -3214,7 +3214,7 @@
               </a:defRPr>
             </a:pPr>
             <a:r>
-              <a:t>Segmentasi Permukaan Dapat-Dipijak pada Point Cloud Anak Tangga</a:t>
+              <a:t>Steppable-Surface Segmentation in Simulated Staircase Point Clouds</a:t>
             </a:r>
           </a:p>
           <a:p>
@@ -3226,7 +3226,7 @@
               </a:defRPr>
             </a:pPr>
             <a:r>
-              <a:t>Perbandingan RANSAC, Analisis Normal PCA, DBSCAN, dan Histogram Ketinggian</a:t>
+              <a:t>A Comparison of RANSAC, PCA Normal Analysis, DBSCAN, and Height-Histogram Methods</a:t>
             </a:r>
           </a:p>
         </p:txBody>
@@ -3273,7 +3273,7 @@
               </a:defRPr>
             </a:pPr>
             <a:r>
-              <a:t>Magister Teknik Elektro - Politeknik Elektronika Negeri Surabaya (PENS)</a:t>
+              <a:t>Master Program in Electrical Engineering - Politeknik Elektronika Negeri Surabaya (PENS)</a:t>
             </a:r>
           </a:p>
           <a:p>
@@ -3285,7 +3285,7 @@
               </a:defRPr>
             </a:pPr>
             <a:r>
-              <a:t>Mata Kuliah: Sensor dan Sistem Pengolahan Sinyal (UAS)</a:t>
+              <a:t>Course: Sensor and Signal Processing Systems (Final Project)</a:t>
             </a:r>
           </a:p>
         </p:txBody>
@@ -3382,7 +3382,7 @@
               </a:defRPr>
             </a:pPr>
             <a:r>
-              <a:t>Latar Belakang &amp; Tujuan</a:t>
+              <a:t>Background &amp; Objectives</a:t>
             </a:r>
           </a:p>
           <a:p>
@@ -3394,7 +3394,7 @@
               </a:defRPr>
             </a:pPr>
             <a:r>
-              <a:t>Pendahuluan</a:t>
+              <a:t>Introduction</a:t>
             </a:r>
           </a:p>
         </p:txBody>
@@ -3402,38 +3402,6 @@
       <p:sp>
         <p:nvSpPr>
           <p:cNvPr id="4" name="TextBox 3"/>
-          <p:cNvSpPr txBox="1"/>
-          <p:nvPr/>
-        </p:nvSpPr>
-        <p:spPr>
-          <a:xfrm>
-            <a:off x="11185855" y="6355080"/>
-            <a:ext cx="822960" cy="365760"/>
-          </a:xfrm>
-          <a:prstGeom prst="rect">
-            <a:avLst/>
-          </a:prstGeom>
-          <a:noFill/>
-        </p:spPr>
-        <p:txBody>
-          <a:bodyPr wrap="none">
-            <a:spAutoFit/>
-          </a:bodyPr>
-          <a:lstStyle/>
-          <a:p>
-            <a:pPr algn="l">
-              <a:defRPr sz="1200" b="0">
-                <a:solidFill>
-                  <a:srgbClr val="666666"/>
-                </a:solidFill>
-              </a:defRPr>
-            </a:pPr>
-          </a:p>
-        </p:txBody>
-      </p:sp>
-      <p:sp>
-        <p:nvSpPr>
-          <p:cNvPr id="5" name="TextBox 4"/>
           <p:cNvSpPr txBox="1"/>
           <p:nvPr/>
         </p:nvSpPr>
@@ -3464,7 +3432,7 @@
               </a:defRPr>
             </a:pPr>
             <a:r>
-              <a:t>•  Robot pemanjat/pengikut tangga &amp; alat bantu tunanetra butuh deteksi 3D yang andal.</a:t>
+              <a:t>•  Stair-climbing/following robots and assistive devices need reliable 3D perception.</a:t>
             </a:r>
           </a:p>
           <a:p>
@@ -3479,7 +3447,7 @@
               </a:defRPr>
             </a:pPr>
             <a:r>
-              <a:t>•  Harus bedakan permukaan dapat-dipijak (tread) dari bagian vertikal (riser) &amp; noise.</a:t>
+              <a:t>•  Must separate steppable surfaces (tread) from vertical faces (riser) and noise.</a:t>
             </a:r>
           </a:p>
           <a:p>
@@ -3494,7 +3462,7 @@
               </a:defRPr>
             </a:pPr>
             <a:r>
-              <a:t>  –  Salah label riser jadi 'dapat dipijak' -&gt; pijakan ke bidang vertikal -&gt; bahaya jatuh.</a:t>
+              <a:t>  –  Mislabeling a riser as steppable -&gt; foothold onto a vertical face -&gt; fall hazard.</a:t>
             </a:r>
           </a:p>
           <a:p>
@@ -3509,7 +3477,7 @@
               </a:defRPr>
             </a:pPr>
             <a:r>
-              <a:t>•  Metode deep learning butuh data berlabel besar &amp; kurang interpretable.</a:t>
+              <a:t>•  Deep-learning methods need large labeled data and lack interpretability.</a:t>
             </a:r>
           </a:p>
           <a:p>
@@ -3524,7 +3492,7 @@
               </a:defRPr>
             </a:pPr>
             <a:r>
-              <a:t>  –  Belum ada benchmark terkontrol dengan ground-truth eksak untuk sub-masalah ini.</a:t>
+              <a:t>  –  No controlled benchmark with exact ground-truth labels for this sub-problem.</a:t>
             </a:r>
           </a:p>
           <a:p>
@@ -3539,7 +3507,7 @@
               </a:defRPr>
             </a:pPr>
             <a:r>
-              <a:t>Tujuan:</a:t>
+              <a:t>Objectives:</a:t>
             </a:r>
           </a:p>
           <a:p>
@@ -3554,7 +3522,7 @@
               </a:defRPr>
             </a:pPr>
             <a:r>
-              <a:t>  –  Generasi point cloud anak tangga 4-step dari model matematis berlabel.</a:t>
+              <a:t>  –  Generate a labeled 4-step staircase point cloud from a mathematical model.</a:t>
             </a:r>
           </a:p>
           <a:p>
@@ -3569,7 +3537,7 @@
               </a:defRPr>
             </a:pPr>
             <a:r>
-              <a:t>  –  Implementasi &amp; bandingkan 4 metode geometris klasik.</a:t>
+              <a:t>  –  Implement and compare four classical geometric methods.</a:t>
             </a:r>
           </a:p>
           <a:p>
@@ -3584,7 +3552,7 @@
               </a:defRPr>
             </a:pPr>
             <a:r>
-              <a:t>  –  Evaluasi kuantitatif + analisis noise + diskusi keamanan robot.</a:t>
+              <a:t>  –  Quantitative evaluation + noise analysis + robot-safety discussion.</a:t>
             </a:r>
           </a:p>
         </p:txBody>
@@ -3681,7 +3649,7 @@
               </a:defRPr>
             </a:pPr>
             <a:r>
-              <a:t>Generasi Data Point Cloud</a:t>
+              <a:t>Point Cloud Data Generation</a:t>
             </a:r>
           </a:p>
           <a:p>
@@ -3693,7 +3661,7 @@
               </a:defRPr>
             </a:pPr>
             <a:r>
-              <a:t>Model matematis 4-step</a:t>
+              <a:t>Mathematical 4-step model</a:t>
             </a:r>
           </a:p>
         </p:txBody>
@@ -3701,38 +3669,6 @@
       <p:sp>
         <p:nvSpPr>
           <p:cNvPr id="4" name="TextBox 3"/>
-          <p:cNvSpPr txBox="1"/>
-          <p:nvPr/>
-        </p:nvSpPr>
-        <p:spPr>
-          <a:xfrm>
-            <a:off x="11185855" y="6355080"/>
-            <a:ext cx="822960" cy="365760"/>
-          </a:xfrm>
-          <a:prstGeom prst="rect">
-            <a:avLst/>
-          </a:prstGeom>
-          <a:noFill/>
-        </p:spPr>
-        <p:txBody>
-          <a:bodyPr wrap="none">
-            <a:spAutoFit/>
-          </a:bodyPr>
-          <a:lstStyle/>
-          <a:p>
-            <a:pPr algn="l">
-              <a:defRPr sz="1200" b="0">
-                <a:solidFill>
-                  <a:srgbClr val="666666"/>
-                </a:solidFill>
-              </a:defRPr>
-            </a:pPr>
-          </a:p>
-        </p:txBody>
-      </p:sp>
-      <p:sp>
-        <p:nvSpPr>
-          <p:cNvPr id="5" name="TextBox 4"/>
           <p:cNvSpPr txBox="1"/>
           <p:nvPr/>
         </p:nvSpPr>
@@ -3763,7 +3699,7 @@
               </a:defRPr>
             </a:pPr>
             <a:r>
-              <a:t>•  Parameter: lebar w=2.5 m, kedalaman d=0.30 m, tinggi h=0.18 m, N=4 step.</a:t>
+              <a:t>•  Parameters: width w=2.5 m, depth d=0.30 m, height h=0.18 m, N=4 steps.</a:t>
             </a:r>
           </a:p>
           <a:p>
@@ -3838,7 +3774,7 @@
               </a:defRPr>
             </a:pPr>
             <a:r>
-              <a:t>•  + outlier acak ~4% dan jitter LiDAR N(0,0.005²).</a:t>
+              <a:t>•  + ~4% random outliers and LiDAR jitter N(0,0.005²).</a:t>
             </a:r>
           </a:p>
           <a:p>
@@ -3853,14 +3789,14 @@
               </a:defRPr>
             </a:pPr>
             <a:r>
-              <a:t>Total 18,333 titik (12,800 tread / 4,800 riser / 733 other).</a:t>
+              <a:t>Total 18,333 points (12,800 tread / 4,800 riser / 733 other).</a:t>
             </a:r>
           </a:p>
         </p:txBody>
       </p:sp>
       <p:pic>
         <p:nvPicPr>
-          <p:cNvPr id="6" name="Picture 5" descr="profile_ground_truth.png"/>
+          <p:cNvPr id="5" name="Picture 4" descr="profile_ground_truth.png"/>
           <p:cNvPicPr>
             <a:picLocks noChangeAspect="1"/>
           </p:cNvPicPr>
@@ -3884,7 +3820,7 @@
       </p:pic>
       <p:sp>
         <p:nvSpPr>
-          <p:cNvPr id="7" name="TextBox 6"/>
+          <p:cNvPr id="6" name="TextBox 5"/>
           <p:cNvSpPr txBox="1"/>
           <p:nvPr/>
         </p:nvSpPr>
@@ -3912,7 +3848,7 @@
               </a:defRPr>
             </a:pPr>
             <a:r>
-              <a:t>Profil samping (y-z): hijau=tread, merah=riser, abu=lainnya</a:t>
+              <a:t>Side profile (y-z): green=tread, red=riser, grey=other</a:t>
             </a:r>
           </a:p>
         </p:txBody>
@@ -4009,7 +3945,7 @@
               </a:defRPr>
             </a:pPr>
             <a:r>
-              <a:t>Empat Metode Segmentasi</a:t>
+              <a:t>Four Segmentation Methods</a:t>
             </a:r>
           </a:p>
           <a:p>
@@ -4021,7 +3957,7 @@
               </a:defRPr>
             </a:pPr>
             <a:r>
-              <a:t>Skema 3 kelas: tread / riser / lainnya</a:t>
+              <a:t>Three-class scheme: tread / riser / other</a:t>
             </a:r>
           </a:p>
         </p:txBody>
@@ -4029,38 +3965,6 @@
       <p:sp>
         <p:nvSpPr>
           <p:cNvPr id="4" name="TextBox 3"/>
-          <p:cNvSpPr txBox="1"/>
-          <p:nvPr/>
-        </p:nvSpPr>
-        <p:spPr>
-          <a:xfrm>
-            <a:off x="11185855" y="6355080"/>
-            <a:ext cx="822960" cy="365760"/>
-          </a:xfrm>
-          <a:prstGeom prst="rect">
-            <a:avLst/>
-          </a:prstGeom>
-          <a:noFill/>
-        </p:spPr>
-        <p:txBody>
-          <a:bodyPr wrap="none">
-            <a:spAutoFit/>
-          </a:bodyPr>
-          <a:lstStyle/>
-          <a:p>
-            <a:pPr algn="l">
-              <a:defRPr sz="1200" b="0">
-                <a:solidFill>
-                  <a:srgbClr val="666666"/>
-                </a:solidFill>
-              </a:defRPr>
-            </a:pPr>
-          </a:p>
-        </p:txBody>
-      </p:sp>
-      <p:sp>
-        <p:nvSpPr>
-          <p:cNvPr id="5" name="TextBox 4"/>
           <p:cNvSpPr txBox="1"/>
           <p:nvPr/>
         </p:nvSpPr>
@@ -4106,7 +4010,7 @@
               </a:defRPr>
             </a:pPr>
             <a:r>
-              <a:t>  –  Fase horizontal -&gt; tread, fase vertikal -&gt; riser; tolak bidang 'ramp' miring.</a:t>
+              <a:t>  –  Horizontal phase -&gt; tread, vertical phase -&gt; riser; rejects the oblique 'ramp' plane.</a:t>
             </a:r>
           </a:p>
           <a:p>
@@ -4121,7 +4025,7 @@
               </a:defRPr>
             </a:pPr>
             <a:r>
-              <a:t>2. Analisis Normal PCA</a:t>
+              <a:t>2. PCA Normal Analysis</a:t>
             </a:r>
           </a:p>
           <a:p>
@@ -4136,7 +4040,7 @@
               </a:defRPr>
             </a:pPr>
             <a:r>
-              <a:t>  –  Normal per-titik via PCA k-NN; klasifikasi dari kemiringan |n·z|.</a:t>
+              <a:t>  –  Per-point normals via PCA over k-NN; classified by tilt |n·z|.</a:t>
             </a:r>
           </a:p>
           <a:p>
@@ -4151,7 +4055,7 @@
               </a:defRPr>
             </a:pPr>
             <a:r>
-              <a:t>3. DBSCAN + Analisis Kemiringan</a:t>
+              <a:t>3. DBSCAN + Slope Analysis</a:t>
             </a:r>
           </a:p>
           <a:p>
@@ -4166,7 +4070,7 @@
               </a:defRPr>
             </a:pPr>
             <a:r>
-              <a:t>  –  Split orientasi -&gt; klaster spasial -&gt; konfirmasi slope tiap klaster.</a:t>
+              <a:t>  –  Orientation split -&gt; spatial clustering -&gt; per-cluster slope confirmation.</a:t>
             </a:r>
           </a:p>
           <a:p>
@@ -4181,7 +4085,7 @@
               </a:defRPr>
             </a:pPr>
             <a:r>
-              <a:t>4. Analisis Histogram Ketinggian (lanjutan)</a:t>
+              <a:t>4. Height-Histogram Analysis (advanced)</a:t>
             </a:r>
           </a:p>
           <a:p>
@@ -4196,7 +4100,7 @@
               </a:defRPr>
             </a:pPr>
             <a:r>
-              <a:t>  –  Puncak histogram z = level tread; pita antar-level = riser.</a:t>
+              <a:t>  –  Peaks of the z-histogram = tread levels; bands between = riser.</a:t>
             </a:r>
           </a:p>
           <a:p>
@@ -4211,7 +4115,7 @@
               </a:defRPr>
             </a:pPr>
             <a:r>
-              <a:t>Wajib min. 2 metode -&gt; diimplementasikan 4 untuk perbandingan menyeluruh.</a:t>
+              <a:t>Minimum 2 methods required -&gt; 4 implemented for a thorough comparison.</a:t>
             </a:r>
           </a:p>
         </p:txBody>
@@ -4308,7 +4212,7 @@
               </a:defRPr>
             </a:pPr>
             <a:r>
-              <a:t>Metodologi &amp; Algoritma</a:t>
+              <a:t>Methodology &amp; Algorithms</a:t>
             </a:r>
           </a:p>
           <a:p>
@@ -4320,7 +4224,7 @@
               </a:defRPr>
             </a:pPr>
             <a:r>
-              <a:t>Rumus inti</a:t>
+              <a:t>Core formulas</a:t>
             </a:r>
           </a:p>
         </p:txBody>
@@ -4328,38 +4232,6 @@
       <p:sp>
         <p:nvSpPr>
           <p:cNvPr id="4" name="TextBox 3"/>
-          <p:cNvSpPr txBox="1"/>
-          <p:nvPr/>
-        </p:nvSpPr>
-        <p:spPr>
-          <a:xfrm>
-            <a:off x="11185855" y="6355080"/>
-            <a:ext cx="822960" cy="365760"/>
-          </a:xfrm>
-          <a:prstGeom prst="rect">
-            <a:avLst/>
-          </a:prstGeom>
-          <a:noFill/>
-        </p:spPr>
-        <p:txBody>
-          <a:bodyPr wrap="none">
-            <a:spAutoFit/>
-          </a:bodyPr>
-          <a:lstStyle/>
-          <a:p>
-            <a:pPr algn="l">
-              <a:defRPr sz="1200" b="0">
-                <a:solidFill>
-                  <a:srgbClr val="666666"/>
-                </a:solidFill>
-              </a:defRPr>
-            </a:pPr>
-          </a:p>
-        </p:txBody>
-      </p:sp>
-      <p:sp>
-        <p:nvSpPr>
-          <p:cNvPr id="5" name="TextBox 4"/>
           <p:cNvSpPr txBox="1"/>
           <p:nvPr/>
         </p:nvSpPr>
@@ -4390,7 +4262,7 @@
               </a:defRPr>
             </a:pPr>
             <a:r>
-              <a:t>RANSAC: jarak titik ke bidang</a:t>
+              <a:t>RANSAC: point-to-plane distance</a:t>
             </a:r>
           </a:p>
           <a:p>
@@ -4405,7 +4277,7 @@
               </a:defRPr>
             </a:pPr>
             <a:r>
-              <a:t>  –  d(x)=|n·x+b|,  inlier I={x: d(x)&lt;τ},  τ=0.035 m</a:t>
+              <a:t>  –  d(x)=|n·x+b|,  inliers I={x: d(x)&lt;τ},  τ=0.035 m</a:t>
             </a:r>
           </a:p>
           <a:p>
@@ -4420,7 +4292,7 @@
               </a:defRPr>
             </a:pPr>
             <a:r>
-              <a:t>  –  Gate orientasi: horizontal |n·z|≥0.93 (tread), vertikal ≤0.25 (riser).</a:t>
+              <a:t>  –  Orientation gate: horizontal |n·z|≥0.93 (tread), vertical ≤0.25 (riser).</a:t>
             </a:r>
           </a:p>
           <a:p>
@@ -4435,7 +4307,7 @@
               </a:defRPr>
             </a:pPr>
             <a:r>
-              <a:t>PCA Normal: kovarians lokal k-NN (k=50)</a:t>
+              <a:t>PCA Normal: local k-NN covariance (k=50)</a:t>
             </a:r>
           </a:p>
           <a:p>
@@ -4465,7 +4337,7 @@
               </a:defRPr>
             </a:pPr>
             <a:r>
-              <a:t>  –  Tread |n·z|≥0.80, riser ≤0.50 (lebih longgar: normal per-titik lebih noisy).</a:t>
+              <a:t>  –  Tread |n·z|≥0.80, riser ≤0.50 (looser: per-point normals are noisier).</a:t>
             </a:r>
           </a:p>
           <a:p>
@@ -4480,7 +4352,7 @@
               </a:defRPr>
             </a:pPr>
             <a:r>
-              <a:t>DBSCAN: ε=0.08 m dalam tiap grup orientasi, lalu konfirmasi slope.</a:t>
+              <a:t>DBSCAN: ε=0.08 m within each orientation group, then slope confirmation.</a:t>
             </a:r>
           </a:p>
           <a:p>
@@ -4495,7 +4367,7 @@
               </a:defRPr>
             </a:pPr>
             <a:r>
-              <a:t>•  Bidang 'ramp' global stair: |n·z|=d/√(d²+h²)≈0.86 -&gt; alasan gate orientasi.</a:t>
+              <a:t>•  Global stair 'ramp' plane: |n·z|=d/√(d²+h²)≈0.86 -&gt; motivates the orientation gate.</a:t>
             </a:r>
           </a:p>
         </p:txBody>
@@ -4592,7 +4464,7 @@
               </a:defRPr>
             </a:pPr>
             <a:r>
-              <a:t>Hasil Eksperimen</a:t>
+              <a:t>Experimental Results</a:t>
             </a:r>
           </a:p>
           <a:p>
@@ -4604,46 +4476,14 @@
               </a:defRPr>
             </a:pPr>
             <a:r>
-              <a:t>Metrik kelas tread (one-vs-rest)</a:t>
-            </a:r>
-          </a:p>
-        </p:txBody>
-      </p:sp>
-      <p:sp>
-        <p:nvSpPr>
-          <p:cNvPr id="4" name="TextBox 3"/>
-          <p:cNvSpPr txBox="1"/>
-          <p:nvPr/>
-        </p:nvSpPr>
-        <p:spPr>
-          <a:xfrm>
-            <a:off x="11185855" y="6355080"/>
-            <a:ext cx="822960" cy="365760"/>
-          </a:xfrm>
-          <a:prstGeom prst="rect">
-            <a:avLst/>
-          </a:prstGeom>
-          <a:noFill/>
-        </p:spPr>
-        <p:txBody>
-          <a:bodyPr wrap="none">
-            <a:spAutoFit/>
-          </a:bodyPr>
-          <a:lstStyle/>
-          <a:p>
-            <a:pPr algn="l">
-              <a:defRPr sz="1200" b="0">
-                <a:solidFill>
-                  <a:srgbClr val="666666"/>
-                </a:solidFill>
-              </a:defRPr>
-            </a:pPr>
+              <a:t>Tread-class metrics (one-vs-rest)</a:t>
+            </a:r>
           </a:p>
         </p:txBody>
       </p:sp>
       <p:graphicFrame>
         <p:nvGraphicFramePr>
-          <p:cNvPr id="5" name="Table 4"/>
+          <p:cNvPr id="4" name="Table 3"/>
           <p:cNvGraphicFramePr>
             <a:graphicFrameLocks noGrp="1"/>
           </p:cNvGraphicFramePr>
@@ -4681,7 +4521,7 @@
                         </a:defRPr>
                       </a:pPr>
                       <a:r>
-                        <a:t>Metode</a:t>
+                        <a:t>Method</a:t>
                       </a:r>
                     </a:p>
                   </a:txBody>
@@ -5201,7 +5041,7 @@
       </p:graphicFrame>
       <p:sp>
         <p:nvSpPr>
-          <p:cNvPr id="6" name="TextBox 5"/>
+          <p:cNvPr id="5" name="TextBox 4"/>
           <p:cNvSpPr txBox="1"/>
           <p:nvPr/>
         </p:nvSpPr>
@@ -5232,7 +5072,7 @@
               </a:defRPr>
             </a:pPr>
             <a:r>
-              <a:t>DBSCAN-Slope terbaik: F1 0.943, IoU 0.892.</a:t>
+              <a:t>DBSCAN-Slope is best: F1 0.943, IoU 0.892.</a:t>
             </a:r>
           </a:p>
           <a:p>
@@ -5247,7 +5087,7 @@
               </a:defRPr>
             </a:pPr>
             <a:r>
-              <a:t>•  PCA-Normals dekat: F1 0.927, presisi tertinggi 0.954.</a:t>
+              <a:t>•  PCA-Normals close behind: F1 0.927, highest precision 0.954.</a:t>
             </a:r>
           </a:p>
           <a:p>
@@ -5262,7 +5102,7 @@
               </a:defRPr>
             </a:pPr>
             <a:r>
-              <a:t>•  Histogram: recall tertinggi 0.984, presisi lebih rendah.</a:t>
+              <a:t>•  Height-Histogram: highest recall 0.984, lower precision.</a:t>
             </a:r>
           </a:p>
           <a:p>
@@ -5277,14 +5117,14 @@
               </a:defRPr>
             </a:pPr>
             <a:r>
-              <a:t>•  RANSAC murni terlemah: presisi 0.714 (riser terserap bidang tread).</a:t>
+              <a:t>•  Plain RANSAC weakest: precision 0.714 (risers absorbed by tread planes).</a:t>
             </a:r>
           </a:p>
         </p:txBody>
       </p:sp>
       <p:pic>
         <p:nvPicPr>
-          <p:cNvPr id="7" name="Picture 6" descr="seg_dbscan_slope.png"/>
+          <p:cNvPr id="6" name="Picture 5" descr="seg_dbscan_slope.png"/>
           <p:cNvPicPr>
             <a:picLocks noChangeAspect="1"/>
           </p:cNvPicPr>
@@ -5308,7 +5148,7 @@
       </p:pic>
       <p:sp>
         <p:nvSpPr>
-          <p:cNvPr id="8" name="TextBox 7"/>
+          <p:cNvPr id="7" name="TextBox 6"/>
           <p:cNvSpPr txBox="1"/>
           <p:nvPr/>
         </p:nvSpPr>
@@ -5336,7 +5176,7 @@
               </a:defRPr>
             </a:pPr>
             <a:r>
-              <a:t>Segmentasi DBSCAN 3D vs ground truth</a:t>
+              <a:t>DBSCAN 3D segmentation vs ground truth</a:t>
             </a:r>
           </a:p>
         </p:txBody>
@@ -5433,7 +5273,7 @@
               </a:defRPr>
             </a:pPr>
             <a:r>
-              <a:t>Visualisasi 3D &amp; Histogram</a:t>
+              <a:t>3D Visualization &amp; Histogram</a:t>
             </a:r>
           </a:p>
           <a:p>
@@ -5445,46 +5285,14 @@
               </a:defRPr>
             </a:pPr>
             <a:r>
-              <a:t>Hasil eksperimen</a:t>
-            </a:r>
-          </a:p>
-        </p:txBody>
-      </p:sp>
-      <p:sp>
-        <p:nvSpPr>
-          <p:cNvPr id="4" name="TextBox 3"/>
-          <p:cNvSpPr txBox="1"/>
-          <p:nvPr/>
-        </p:nvSpPr>
-        <p:spPr>
-          <a:xfrm>
-            <a:off x="11185855" y="6355080"/>
-            <a:ext cx="822960" cy="365760"/>
-          </a:xfrm>
-          <a:prstGeom prst="rect">
-            <a:avLst/>
-          </a:prstGeom>
-          <a:noFill/>
-        </p:spPr>
-        <p:txBody>
-          <a:bodyPr wrap="none">
-            <a:spAutoFit/>
-          </a:bodyPr>
-          <a:lstStyle/>
-          <a:p>
-            <a:pPr algn="l">
-              <a:defRPr sz="1200" b="0">
-                <a:solidFill>
-                  <a:srgbClr val="666666"/>
-                </a:solidFill>
-              </a:defRPr>
-            </a:pPr>
+              <a:t>Experimental results</a:t>
+            </a:r>
           </a:p>
         </p:txBody>
       </p:sp>
       <p:pic>
         <p:nvPicPr>
-          <p:cNvPr id="5" name="Picture 4" descr="height_histogram.png"/>
+          <p:cNvPr id="4" name="Picture 3" descr="height_histogram.png"/>
           <p:cNvPicPr>
             <a:picLocks noChangeAspect="1"/>
           </p:cNvPicPr>
@@ -5508,7 +5316,7 @@
       </p:pic>
       <p:sp>
         <p:nvSpPr>
-          <p:cNvPr id="6" name="TextBox 5"/>
+          <p:cNvPr id="5" name="TextBox 4"/>
           <p:cNvSpPr txBox="1"/>
           <p:nvPr/>
         </p:nvSpPr>
@@ -5536,14 +5344,14 @@
               </a:defRPr>
             </a:pPr>
             <a:r>
-              <a:t>Histogram ketinggian: 4 level tread terdeteksi (z≈0,0.18,0.36,0.54 m)</a:t>
+              <a:t>Height histogram: 4 tread levels detected (z≈0,0.18,0.36,0.54 m)</a:t>
             </a:r>
           </a:p>
         </p:txBody>
       </p:sp>
       <p:pic>
         <p:nvPicPr>
-          <p:cNvPr id="7" name="Picture 6" descr="seg_pca_normals.png"/>
+          <p:cNvPr id="6" name="Picture 5" descr="seg_pca_normals.png"/>
           <p:cNvPicPr>
             <a:picLocks noChangeAspect="1"/>
           </p:cNvPicPr>
@@ -5567,7 +5375,7 @@
       </p:pic>
       <p:sp>
         <p:nvSpPr>
-          <p:cNvPr id="8" name="TextBox 7"/>
+          <p:cNvPr id="7" name="TextBox 6"/>
           <p:cNvSpPr txBox="1"/>
           <p:nvPr/>
         </p:nvSpPr>
@@ -5595,14 +5403,14 @@
               </a:defRPr>
             </a:pPr>
             <a:r>
-              <a:t>Segmentasi PCA-Normals 3D (kiri GT, kanan hasil)</a:t>
-            </a:r>
-          </a:p>
-        </p:txBody>
-      </p:sp>
-      <p:sp>
-        <p:nvSpPr>
-          <p:cNvPr id="9" name="TextBox 8"/>
+              <a:t>PCA-Normals 3D segmentation (left GT, right result)</a:t>
+            </a:r>
+          </a:p>
+        </p:txBody>
+      </p:sp>
+      <p:sp>
+        <p:nvSpPr>
+          <p:cNvPr id="8" name="TextBox 7"/>
           <p:cNvSpPr txBox="1"/>
           <p:nvPr/>
         </p:nvSpPr>
@@ -5633,7 +5441,7 @@
               </a:defRPr>
             </a:pPr>
             <a:r>
-              <a:t>•  Tiap tread jadi level z tajam; riser mengisi pita antar-level.</a:t>
+              <a:t>•  Each tread forms a sharp z-level; risers fill the bands between levels.</a:t>
             </a:r>
           </a:p>
           <a:p>
@@ -5648,7 +5456,7 @@
               </a:defRPr>
             </a:pPr>
             <a:r>
-              <a:t>•  Hijau=tread, merah=riser, abu=lainnya/outlier.</a:t>
+              <a:t>•  Green=tread, red=riser, grey=other/outlier.</a:t>
             </a:r>
           </a:p>
         </p:txBody>
@@ -5745,7 +5553,7 @@
               </a:defRPr>
             </a:pPr>
             <a:r>
-              <a:t>Analisis Noise &amp; Keamanan Robot</a:t>
+              <a:t>Noise Analysis &amp; Robot Safety</a:t>
             </a:r>
           </a:p>
           <a:p>
@@ -5757,46 +5565,14 @@
               </a:defRPr>
             </a:pPr>
             <a:r>
-              <a:t>Diskusi</a:t>
-            </a:r>
-          </a:p>
-        </p:txBody>
-      </p:sp>
-      <p:sp>
-        <p:nvSpPr>
-          <p:cNvPr id="4" name="TextBox 3"/>
-          <p:cNvSpPr txBox="1"/>
-          <p:nvPr/>
-        </p:nvSpPr>
-        <p:spPr>
-          <a:xfrm>
-            <a:off x="11185855" y="6355080"/>
-            <a:ext cx="822960" cy="365760"/>
-          </a:xfrm>
-          <a:prstGeom prst="rect">
-            <a:avLst/>
-          </a:prstGeom>
-          <a:noFill/>
-        </p:spPr>
-        <p:txBody>
-          <a:bodyPr wrap="none">
-            <a:spAutoFit/>
-          </a:bodyPr>
-          <a:lstStyle/>
-          <a:p>
-            <a:pPr algn="l">
-              <a:defRPr sz="1200" b="0">
-                <a:solidFill>
-                  <a:srgbClr val="666666"/>
-                </a:solidFill>
-              </a:defRPr>
-            </a:pPr>
+              <a:t>Discussion</a:t>
+            </a:r>
           </a:p>
         </p:txBody>
       </p:sp>
       <p:pic>
         <p:nvPicPr>
-          <p:cNvPr id="5" name="Picture 4" descr="noise_sensitivity.png"/>
+          <p:cNvPr id="4" name="Picture 3" descr="noise_sensitivity.png"/>
           <p:cNvPicPr>
             <a:picLocks noChangeAspect="1"/>
           </p:cNvPicPr>
@@ -5820,7 +5596,7 @@
       </p:pic>
       <p:sp>
         <p:nvSpPr>
-          <p:cNvPr id="6" name="TextBox 5"/>
+          <p:cNvPr id="5" name="TextBox 4"/>
           <p:cNvSpPr txBox="1"/>
           <p:nvPr/>
         </p:nvSpPr>
@@ -5848,14 +5624,14 @@
               </a:defRPr>
             </a:pPr>
             <a:r>
-              <a:t>F1/IoU tread vs σz (PCA-Normals)</a:t>
-            </a:r>
-          </a:p>
-        </p:txBody>
-      </p:sp>
-      <p:sp>
-        <p:nvSpPr>
-          <p:cNvPr id="7" name="TextBox 6"/>
+              <a:t>Tread F1/IoU vs σz (PCA-Normals)</a:t>
+            </a:r>
+          </a:p>
+        </p:txBody>
+      </p:sp>
+      <p:sp>
+        <p:nvSpPr>
+          <p:cNvPr id="6" name="TextBox 5"/>
           <p:cNvSpPr txBox="1"/>
           <p:nvPr/>
         </p:nvSpPr>
@@ -5886,7 +5662,7 @@
               </a:defRPr>
             </a:pPr>
             <a:r>
-              <a:t>Pengaruh noise:</a:t>
+              <a:t>Effect of noise:</a:t>
             </a:r>
           </a:p>
           <a:p>
@@ -5901,7 +5677,7 @@
               </a:defRPr>
             </a:pPr>
             <a:r>
-              <a:t>  –  F1 turun 0.956 -&gt; 0.543 saat σz 0.01 -&gt; 0.07 m.</a:t>
+              <a:t>  –  F1 drops 0.956 -&gt; 0.543 as σz 0.01 -&gt; 0.07 m.</a:t>
             </a:r>
           </a:p>
           <a:p>
@@ -5916,7 +5692,7 @@
               </a:defRPr>
             </a:pPr>
             <a:r>
-              <a:t>  –  Jatuh tajam saat σz mendekati ½ tinggi step (0.09 m): normal jadi ambigu.</a:t>
+              <a:t>  –  Sharp fall as σz approaches ½ step height (0.09 m): normals become ambiguous.</a:t>
             </a:r>
           </a:p>
           <a:p>
@@ -5931,7 +5707,7 @@
               </a:defRPr>
             </a:pPr>
             <a:r>
-              <a:t>Keamanan robot pengikut tangga:</a:t>
+              <a:t>Safety for stair-following robots:</a:t>
             </a:r>
           </a:p>
           <a:p>
@@ -5946,7 +5722,7 @@
               </a:defRPr>
             </a:pPr>
             <a:r>
-              <a:t>  –  IoU≈0.89 cukup untuk perencanaan pijakan kasar.</a:t>
+              <a:t>  –  IoU≈0.89 is adequate for coarse foothold planning.</a:t>
             </a:r>
           </a:p>
           <a:p>
@@ -5961,7 +5737,7 @@
               </a:defRPr>
             </a:pPr>
             <a:r>
-              <a:t>  –  Presisi &lt;1.0 -&gt; sebagian riser salah label 'dapat dipijak' = risiko.</a:t>
+              <a:t>  –  Precision &lt;1.0 -&gt; some risers mislabeled steppable = hazard.</a:t>
             </a:r>
           </a:p>
           <a:p>
@@ -5976,7 +5752,7 @@
               </a:defRPr>
             </a:pPr>
             <a:r>
-              <a:t>  –  Mitigasi: ensemble voting, margin erosi tepi tread, verifikasi temporal.</a:t>
+              <a:t>  –  Mitigation: ensemble voting, tread-edge erosion margin, temporal verification.</a:t>
             </a:r>
           </a:p>
         </p:txBody>
@@ -6073,7 +5849,7 @@
               </a:defRPr>
             </a:pPr>
             <a:r>
-              <a:t>Kesimpulan</a:t>
+              <a:t>Conclusion</a:t>
             </a:r>
           </a:p>
           <a:p>
@@ -6085,7 +5861,7 @@
               </a:defRPr>
             </a:pPr>
             <a:r>
-              <a:t>Penutup</a:t>
+              <a:t>Summary</a:t>
             </a:r>
           </a:p>
         </p:txBody>
@@ -6093,38 +5869,6 @@
       <p:sp>
         <p:nvSpPr>
           <p:cNvPr id="4" name="TextBox 3"/>
-          <p:cNvSpPr txBox="1"/>
-          <p:nvPr/>
-        </p:nvSpPr>
-        <p:spPr>
-          <a:xfrm>
-            <a:off x="11185855" y="6355080"/>
-            <a:ext cx="822960" cy="365760"/>
-          </a:xfrm>
-          <a:prstGeom prst="rect">
-            <a:avLst/>
-          </a:prstGeom>
-          <a:noFill/>
-        </p:spPr>
-        <p:txBody>
-          <a:bodyPr wrap="none">
-            <a:spAutoFit/>
-          </a:bodyPr>
-          <a:lstStyle/>
-          <a:p>
-            <a:pPr algn="l">
-              <a:defRPr sz="1200" b="0">
-                <a:solidFill>
-                  <a:srgbClr val="666666"/>
-                </a:solidFill>
-              </a:defRPr>
-            </a:pPr>
-          </a:p>
-        </p:txBody>
-      </p:sp>
-      <p:sp>
-        <p:nvSpPr>
-          <p:cNvPr id="5" name="TextBox 4"/>
           <p:cNvSpPr txBox="1"/>
           <p:nvPr/>
         </p:nvSpPr>
@@ -6155,7 +5899,7 @@
               </a:defRPr>
             </a:pPr>
             <a:r>
-              <a:t>•  Benchmark point cloud anak tangga sintetis berlabel penuh + perbandingan 4 metode klasik.</a:t>
+              <a:t>•  A fully labeled synthetic staircase benchmark + comparison of four classical methods.</a:t>
             </a:r>
           </a:p>
           <a:p>
@@ -6170,7 +5914,7 @@
               </a:defRPr>
             </a:pPr>
             <a:r>
-              <a:t>DBSCAN + analisis kemiringan terbaik (F1 0.943, IoU 0.892); RANSAC murni terlemah.</a:t>
+              <a:t>DBSCAN + slope analysis is best (F1 0.943, IoU 0.892); plain RANSAC is weakest.</a:t>
             </a:r>
           </a:p>
           <a:p>
@@ -6185,7 +5929,7 @@
               </a:defRPr>
             </a:pPr>
             <a:r>
-              <a:t>•  Metode berbasis normal (PCA, DBSCAN) unggul: orientasi tread vs riser cue yang kuat.</a:t>
+              <a:t>•  Normal-based methods (PCA, DBSCAN) win: tread vs riser orientation is a strong cue.</a:t>
             </a:r>
           </a:p>
           <a:p>
@@ -6200,7 +5944,7 @@
               </a:defRPr>
             </a:pPr>
             <a:r>
-              <a:t>•  Segmentasi memburuk saat noise mendekati ½ tinggi step.</a:t>
+              <a:t>•  Segmentation degrades as noise approaches half the step height.</a:t>
             </a:r>
           </a:p>
           <a:p>
@@ -6215,7 +5959,7 @@
               </a:defRPr>
             </a:pPr>
             <a:r>
-              <a:t>•  Cukup untuk perencanaan pijakan kasar, perlu margin keamanan sebelum dipakai robot.</a:t>
+              <a:t>•  Adequate for coarse foothold planning; needs safety margins before robot use.</a:t>
             </a:r>
           </a:p>
           <a:p>
@@ -6230,7 +5974,7 @@
               </a:defRPr>
             </a:pPr>
             <a:r>
-              <a:t>•  Arah ke depan: ensemble multi-metode, validasi LiDAR nyata, bandingkan vs deep learning.</a:t>
+              <a:t>•  Future work: multi-method ensemble, real LiDAR validation, comparison vs deep learning.</a:t>
             </a:r>
           </a:p>
           <a:p>
@@ -6245,14 +5989,14 @@
               </a:defRPr>
             </a:pPr>
             <a:r>
-              <a:t>Kode + paper + repo: github.com/riyadh-gif/UAS-citraPraktikum-PakNando</a:t>
-            </a:r>
-          </a:p>
-        </p:txBody>
-      </p:sp>
-      <p:sp>
-        <p:nvSpPr>
-          <p:cNvPr id="6" name="TextBox 5"/>
+              <a:t>Code + paper + repo: github.com/riyadh-gif/UAS-citraPraktikum-PakNando</a:t>
+            </a:r>
+          </a:p>
+        </p:txBody>
+      </p:sp>
+      <p:sp>
+        <p:nvSpPr>
+          <p:cNvPr id="5" name="TextBox 4"/>
           <p:cNvSpPr txBox="1"/>
           <p:nvPr/>
         </p:nvSpPr>
@@ -6280,7 +6024,7 @@
               </a:defRPr>
             </a:pPr>
             <a:r>
-              <a:t>Terima kasih.</a:t>
+              <a:t>Thank you.</a:t>
             </a:r>
           </a:p>
         </p:txBody>

</xml_diff>